<commit_message>
Correct exposure card gutters and mobile grid
</commit_message>
<xml_diff>
--- a/LeakFinder_Round1_Final_updated.pptx
+++ b/LeakFinder_Round1_Final_updated.pptx
@@ -3812,7 +3812,7 @@
       </p:sp>
       <p:pic>
         <p:nvPicPr>
-          <p:cNvPr id="5" name="Picture 4" descr="leakfinder-command-center.png"/>
+          <p:cNvPr id="5" name="Picture 4" descr="image.png"/>
           <p:cNvPicPr>
             <a:picLocks noChangeAspect="1"/>
           </p:cNvPicPr>
@@ -3993,7 +3993,7 @@
           <p:nvPr/>
         </p:nvPicPr>
         <p:blipFill>
-          <a:blip r:embed="rId3"/>
+          <a:blip r:embed="rId4"/>
           <a:stretch>
             <a:fillRect/>
           </a:stretch>
@@ -4070,16 +4070,52 @@
           </a:p>
         </p:txBody>
       </p:sp>
+      <p:sp>
+        <p:nvSpPr>
+          <p:cNvPr id="4" name="TextBox 3"/>
+          <p:cNvSpPr txBox="1"/>
+          <p:nvPr/>
+        </p:nvSpPr>
+        <p:spPr>
+          <a:xfrm>
+            <a:off x="502920" y="6565392"/>
+            <a:ext cx="11186160" cy="182880"/>
+          </a:xfrm>
+          <a:prstGeom prst="rect">
+            <a:avLst/>
+          </a:prstGeom>
+          <a:noFill/>
+        </p:spPr>
+        <p:txBody>
+          <a:bodyPr wrap="none">
+            <a:spAutoFit/>
+          </a:bodyPr>
+          <a:lstStyle/>
+          <a:p>
+            <a:pPr algn="r">
+              <a:defRPr sz="900">
+                <a:solidFill>
+                  <a:srgbClr val="94A3B8"/>
+                </a:solidFill>
+                <a:latin typeface="Aptos"/>
+              </a:defRPr>
+            </a:pPr>
+            <a:r>
+              <a:t>W V P S SRIRAJ (23BCE8414)</a:t>
+            </a:r>
+          </a:p>
+        </p:txBody>
+      </p:sp>
       <p:pic>
         <p:nvPicPr>
-          <p:cNvPr id="3" name="Picture 2" descr="leakfinder-exposure.png"/>
+          <p:cNvPr id="5" name="Picture 4" descr="leakfinder-exposure.png"/>
           <p:cNvPicPr>
             <a:picLocks noChangeAspect="1"/>
           </p:cNvPicPr>
           <p:nvPr/>
         </p:nvPicPr>
         <p:blipFill>
-          <a:blip r:embed="rId2"/>
+          <a:blip r:embed="rId3"/>
           <a:stretch>
             <a:fillRect/>
           </a:stretch>
@@ -4094,42 +4130,6 @@
           </a:prstGeom>
         </p:spPr>
       </p:pic>
-      <p:sp>
-        <p:nvSpPr>
-          <p:cNvPr id="4" name="TextBox 3"/>
-          <p:cNvSpPr txBox="1"/>
-          <p:nvPr/>
-        </p:nvSpPr>
-        <p:spPr>
-          <a:xfrm>
-            <a:off x="502920" y="6565392"/>
-            <a:ext cx="11186160" cy="182880"/>
-          </a:xfrm>
-          <a:prstGeom prst="rect">
-            <a:avLst/>
-          </a:prstGeom>
-          <a:noFill/>
-        </p:spPr>
-        <p:txBody>
-          <a:bodyPr wrap="none">
-            <a:spAutoFit/>
-          </a:bodyPr>
-          <a:lstStyle/>
-          <a:p>
-            <a:pPr algn="r">
-              <a:defRPr sz="900">
-                <a:solidFill>
-                  <a:srgbClr val="94A3B8"/>
-                </a:solidFill>
-                <a:latin typeface="Aptos"/>
-              </a:defRPr>
-            </a:pPr>
-            <a:r>
-              <a:t>W V P S SRIRAJ (23BCE8414)</a:t>
-            </a:r>
-          </a:p>
-        </p:txBody>
-      </p:sp>
     </p:spTree>
   </p:cSld>
   <p:clrMapOvr>
@@ -9149,7 +9149,7 @@
           <p:nvPr/>
         </p:nvPicPr>
         <p:blipFill>
-          <a:blip r:embed="rId3"/>
+          <a:blip r:embed="rId4"/>
           <a:stretch>
             <a:fillRect/>
           </a:stretch>

</xml_diff>